<commit_message>
feat: Update investor pitch deck and financial model with revised funding scenarios and projections
</commit_message>
<xml_diff>
--- a/KAILA_Founder_Grade_Package/KAILA Founder Presentation/presentation/KAILA_Investor_Pitch_Deck.pptx
+++ b/KAILA_Founder_Grade_Package/KAILA Founder Presentation/presentation/KAILA_Investor_Pitch_Deck.pptx
@@ -4735,7 +4735,7 @@
                 </a:solidFill>
                 <a:latin typeface="Arial"/>
               </a:rPr>
-              <a:t>Lean 3-year model: founder-led pilot before paid marketplace.</a:t>
+              <a:t>Lean 3-year model: micro-budget pilot before paid marketplace.</a:t>
             </a:r>
           </a:p>
         </p:txBody>
@@ -6473,7 +6473,7 @@
                 </a:solidFill>
                 <a:latin typeface="Arial"/>
               </a:rPr>
-              <a:t>PHP 0.3M</a:t>
+              <a:t>PHP 36K</a:t>
             </a:r>
           </a:p>
         </p:txBody>
@@ -6552,7 +6552,7 @@
                 </a:solidFill>
                 <a:latin typeface="Arial"/>
               </a:rPr>
-              <a:t>PHP 0.9M</a:t>
+              <a:t>PHP 60K</a:t>
             </a:r>
           </a:p>
         </p:txBody>
@@ -6631,7 +6631,7 @@
                 </a:solidFill>
                 <a:latin typeface="Arial"/>
               </a:rPr>
-              <a:t>PHP 1.8M</a:t>
+              <a:t>PHP 120K</a:t>
             </a:r>
           </a:p>
         </p:txBody>
@@ -6789,7 +6789,7 @@
                 </a:solidFill>
                 <a:latin typeface="Arial"/>
               </a:rPr>
-              <a:t>(PHP 0.1M)</a:t>
+              <a:t>PHP 144K</a:t>
             </a:r>
           </a:p>
         </p:txBody>
@@ -6868,7 +6868,7 @@
                 </a:solidFill>
                 <a:latin typeface="Arial"/>
               </a:rPr>
-              <a:t>PHP 0.8M</a:t>
+              <a:t>PHP 1.67M</a:t>
             </a:r>
           </a:p>
         </p:txBody>
@@ -6947,7 +6947,7 @@
                 </a:solidFill>
                 <a:latin typeface="Arial"/>
               </a:rPr>
-              <a:t>PHP 5.5M</a:t>
+              <a:t>PHP 7.17M</a:t>
             </a:r>
           </a:p>
         </p:txBody>
@@ -7265,7 +7265,7 @@
                 </a:solidFill>
                 <a:latin typeface="Arial"/>
               </a:rPr>
-              <a:t>Seeking lean pilot support after building the first browser MVP and native wrapper.</a:t>
+              <a:t>No large raise needed: optional micro-budget support for the pilot.</a:t>
             </a:r>
           </a:p>
         </p:txBody>
@@ -7344,7 +7344,7 @@
                 </a:solidFill>
                 <a:latin typeface="Arial"/>
               </a:rPr>
-              <a:t>20%</a:t>
+              <a:t>10%</a:t>
             </a:r>
           </a:p>
         </p:txBody>
@@ -7412,7 +7412,7 @@
                 </a:solidFill>
                 <a:latin typeface="Arial"/>
               </a:rPr>
-              <a:t>PHP 100,000</a:t>
+              <a:t>PHP 5,000</a:t>
             </a:r>
           </a:p>
         </p:txBody>
@@ -7491,7 +7491,7 @@
                 </a:solidFill>
                 <a:latin typeface="Arial"/>
               </a:rPr>
-              <a:t>35%</a:t>
+              <a:t>40%</a:t>
             </a:r>
           </a:p>
         </p:txBody>
@@ -7525,7 +7525,7 @@
                 </a:solidFill>
                 <a:latin typeface="Arial"/>
               </a:rPr>
-              <a:t>Local marketing</a:t>
+              <a:t>Page/content boosts</a:t>
             </a:r>
           </a:p>
         </p:txBody>
@@ -7559,7 +7559,7 @@
                 </a:solidFill>
                 <a:latin typeface="Arial"/>
               </a:rPr>
-              <a:t>PHP 175,000</a:t>
+              <a:t>PHP 20,000</a:t>
             </a:r>
           </a:p>
         </p:txBody>
@@ -7672,7 +7672,7 @@
                 </a:solidFill>
                 <a:latin typeface="Arial"/>
               </a:rPr>
-              <a:t>Operations</a:t>
+              <a:t>Field ops</a:t>
             </a:r>
           </a:p>
         </p:txBody>
@@ -7706,7 +7706,7 @@
                 </a:solidFill>
                 <a:latin typeface="Arial"/>
               </a:rPr>
-              <a:t>PHP 150,000</a:t>
+              <a:t>PHP 15,000</a:t>
             </a:r>
           </a:p>
         </p:txBody>
@@ -7785,7 +7785,7 @@
                 </a:solidFill>
                 <a:latin typeface="Arial"/>
               </a:rPr>
-              <a:t>15%</a:t>
+              <a:t>20%</a:t>
             </a:r>
           </a:p>
         </p:txBody>
@@ -7819,7 +7819,7 @@
                 </a:solidFill>
                 <a:latin typeface="Arial"/>
               </a:rPr>
-              <a:t>Legal/Admin</a:t>
+              <a:t>Admin buffer</a:t>
             </a:r>
           </a:p>
         </p:txBody>
@@ -7853,7 +7853,7 @@
                 </a:solidFill>
                 <a:latin typeface="Arial"/>
               </a:rPr>
-              <a:t>PHP 75,000</a:t>
+              <a:t>PHP 10,000</a:t>
             </a:r>
           </a:p>
         </p:txBody>
@@ -7887,7 +7887,7 @@
                 </a:solidFill>
                 <a:latin typeface="Arial"/>
               </a:rPr>
-              <a:t>Use free resources first; paid spend should support only field validation, page growth, support, and essential app polish.</a:t>
+              <a:t>Use free resources first; this optional PHP 50,000 ceiling covers only small boosts, field validation, and essentials.</a:t>
             </a:r>
           </a:p>
         </p:txBody>

</xml_diff>